<commit_message>
docs: update team member names in SRS, manual, and PPT
</commit_message>
<xml_diff>
--- a/T11-介绍PPT-v2.pptx
+++ b/T11-介绍PPT-v2.pptx
@@ -3294,7 +3294,7 @@
               </a:defRPr>
             </a:pPr>
             <a:r>
-              <a:t>中国社会科学院大学 · 2025级会计专硕二班 · 尚浩然</a:t>
+              <a:t>中国社会科学院大学 · 2025级会计专硕二班 · 尚浩然、李金阳</a:t>
             </a:r>
           </a:p>
         </p:txBody>
@@ -7288,7 +7288,7 @@
               </a:defRPr>
             </a:pPr>
             <a:r>
-              <a:t>中国社会科学院大学 · 2025级MPAcc二班 · 尚浩然 · 指导老师：张金昌</a:t>
+              <a:t>中国社会科学院大学 · 2025级MPAcc二班 · 尚浩然、李金阳 · 指导老师：张金昌</a:t>
             </a:r>
           </a:p>
         </p:txBody>

</xml_diff>